<commit_message>
Mark all synthetic data as EXAMPLE
All customer, branch and test email addresses now use the reserved
.example domain (RFC 2606), so no address can belong to a real person.
Every generated letter carries an EXAMPLE watermark and footer.
Data, letters, reports and the slide deck regenerated; results unchanged.

Co-Authored-By: Claude Opus 5.5 <noreply@anthropic.com>
Claude-Session: https://claude.ai/code/session_01RcpasmBE1hvgdead6uZREF
</commit_message>
<xml_diff>
--- a/presentation/Secure_Customer_Correspondence.pptx
+++ b/presentation/Secure_Customer_Correspondence.pptx
@@ -118,32 +118,32 @@
   <p:extLst>
     <p:ext uri="{521415D9-36F7-43E2-AB2F-B90AF26B5E84}">
       <p14:sectionLst xmlns:p14="http://schemas.microsoft.com/office/powerpoint/2010/main">
-        <p14:section name="Introduction" id="{b5f930da-c47e-3ef9-cdb7-c17541b8d171}">
+        <p14:section name="Introduction" id="{41b07f34-5395-5d23-f755-88a4e9ff3d3b}">
           <p14:sldIdLst>
             <p14:sldId id="256"/>
             <p14:sldId id="257"/>
           </p14:sldIdLst>
         </p14:section>
-        <p14:section name="Problem" id="{8604f7a4-3b3e-6e3a-3ef9-343f6c6d8eb8}">
+        <p14:section name="Problem" id="{f41f3302-40ed-3d06-fbeb-8ffcb9823f4b}">
           <p14:sldIdLst>
             <p14:sldId id="258"/>
             <p14:sldId id="259"/>
           </p14:sldIdLst>
         </p14:section>
-        <p14:section name="Solution" id="{b41b05f8-fd1b-f85b-dd2b-332e972a2693}">
+        <p14:section name="Solution" id="{82e95dc7-f533-9ab1-3f62-dd57bda6ed0b}">
           <p14:sldIdLst>
             <p14:sldId id="260"/>
             <p14:sldId id="261"/>
             <p14:sldId id="262"/>
           </p14:sldIdLst>
         </p14:section>
-        <p14:section name="Evidence" id="{35b29077-c498-06a0-72ae-b32edd31bd76}">
+        <p14:section name="Evidence" id="{49d5cef7-cc38-1bb8-7c7b-b30892034c5e}">
           <p14:sldIdLst>
             <p14:sldId id="263"/>
             <p14:sldId id="264"/>
           </p14:sldIdLst>
         </p14:section>
-        <p14:section name="Impact and next steps" id="{02c53bd0-b541-5b49-da12-d1ebf8932c1a}">
+        <p14:section name="Impact and next steps" id="{41643403-893c-59a2-aa26-0e43199dfb9b}">
           <p14:sldIdLst>
             <p14:sldId id="265"/>
             <p14:sldId id="266"/>
@@ -3540,7 +3540,7 @@
                           <a:ea typeface="Calibri" pitchFamily="34" charset="-122"/>
                           <a:cs typeface="Calibri" pitchFamily="34" charset="-120"/>
                         </a:rPr>
-                        <a:t>~13 seconds</a:t>
+                        <a:t>~12 seconds</a:t>
                       </a:r>
                       <a:endParaRPr lang="en-US" sz="1400" dirty="0">
                         <a:latin typeface="Calibri" charset="0"/>
@@ -5607,7 +5607,7 @@
                   <a:schemeClr val="accent5"/>
                 </a:solidFill>
               </a:rPr>
-              <a:t>~13 s processing per batch</a:t>
+              <a:t>~12 s processing per batch</a:t>
             </a:r>
             <a:endParaRPr lang="en-US" sz="1400" dirty="0"/>
           </a:p>

</xml_diff>

<commit_message>
Store and show only masked personal data
Names, NIK and addresses are now generated and stored already masked
(Budi W*****, 3273********0002, Jl. M****** No. **), and customer emails
no longer contain names (customer.0001@gmail.example). NIK in file names
is detected in masked form; the DP-11 scan now fails on any unmasked,
valid-looking NIK. Test fixtures use the same masked format.
Data, letters, reports, deck and case study regenerated.

Co-Authored-By: Claude Opus 5.5 <noreply@anthropic.com>
Claude-Session: https://claude.ai/code/session_01RcpasmBE1hvgdead6uZREF
</commit_message>
<xml_diff>
--- a/presentation/Secure_Customer_Correspondence.pptx
+++ b/presentation/Secure_Customer_Correspondence.pptx
@@ -118,32 +118,32 @@
   <p:extLst>
     <p:ext uri="{521415D9-36F7-43E2-AB2F-B90AF26B5E84}">
       <p14:sectionLst xmlns:p14="http://schemas.microsoft.com/office/powerpoint/2010/main">
-        <p14:section name="Introduction" id="{41b07f34-5395-5d23-f755-88a4e9ff3d3b}">
+        <p14:section name="Introduction" id="{b2b08ea7-ca9d-2803-ca4f-decde6a15bdc}">
           <p14:sldIdLst>
             <p14:sldId id="256"/>
             <p14:sldId id="257"/>
           </p14:sldIdLst>
         </p14:section>
-        <p14:section name="Problem" id="{f41f3302-40ed-3d06-fbeb-8ffcb9823f4b}">
+        <p14:section name="Problem" id="{ed86d4bc-9534-170a-74ad-59f8310532f6}">
           <p14:sldIdLst>
             <p14:sldId id="258"/>
             <p14:sldId id="259"/>
           </p14:sldIdLst>
         </p14:section>
-        <p14:section name="Solution" id="{82e95dc7-f533-9ab1-3f62-dd57bda6ed0b}">
+        <p14:section name="Solution" id="{6fce0c54-84c1-6b66-bc77-ed6852e0df98}">
           <p14:sldIdLst>
             <p14:sldId id="260"/>
             <p14:sldId id="261"/>
             <p14:sldId id="262"/>
           </p14:sldIdLst>
         </p14:section>
-        <p14:section name="Evidence" id="{49d5cef7-cc38-1bb8-7c7b-b30892034c5e}">
+        <p14:section name="Evidence" id="{7dd509b1-6f24-049a-b0cd-c4cd995df6e1}">
           <p14:sldIdLst>
             <p14:sldId id="263"/>
             <p14:sldId id="264"/>
           </p14:sldIdLst>
         </p14:section>
-        <p14:section name="Impact and next steps" id="{41643403-893c-59a2-aa26-0e43199dfb9b}">
+        <p14:section name="Impact and next steps" id="{ec9a7f95-0493-96a7-9e90-0186852147a9}">
           <p14:sldIdLst>
             <p14:sldId id="265"/>
             <p14:sldId id="266"/>
@@ -298,13 +298,13 @@
                   <c:v>6</c:v>
                 </c:pt>
                 <c:pt idx="3">
-                  <c:v>7</c:v>
+                  <c:v>8</c:v>
                 </c:pt>
                 <c:pt idx="4">
                   <c:v>3</c:v>
                 </c:pt>
                 <c:pt idx="5">
-                  <c:v>6</c:v>
+                  <c:v>7</c:v>
                 </c:pt>
                 <c:pt idx="6">
                   <c:v>6</c:v>
@@ -3540,7 +3540,7 @@
                           <a:ea typeface="Calibri" pitchFamily="34" charset="-122"/>
                           <a:cs typeface="Calibri" pitchFamily="34" charset="-120"/>
                         </a:rPr>
-                        <a:t>~12 seconds</a:t>
+                        <a:t>~13 seconds</a:t>
                       </a:r>
                       <a:endParaRPr lang="en-US" sz="1400" dirty="0">
                         <a:latin typeface="Calibri" charset="0"/>
@@ -4708,7 +4708,7 @@
                   <a:schemeClr val="tx1"/>
                 </a:solidFill>
               </a:rPr>
-              <a:t>Stale and mistyped emails were the top exception (DP-06, 7 held)</a:t>
+              <a:t>Stale and mistyped emails were the top exception (DP-06, 8 held)</a:t>
             </a:r>
             <a:endParaRPr lang="en-US" sz="1400" dirty="0"/>
           </a:p>
@@ -5607,7 +5607,7 @@
                   <a:schemeClr val="accent5"/>
                 </a:solidFill>
               </a:rPr>
-              <a:t>~12 s processing per batch</a:t>
+              <a:t>~13 s processing per batch</a:t>
             </a:r>
             <a:endParaRPr lang="en-US" sz="1400" dirty="0"/>
           </a:p>
@@ -5852,7 +5852,7 @@
                   <a:schemeClr val="accent5"/>
                 </a:solidFill>
               </a:rPr>
-              <a:t>42 of 42 injected defects caught</a:t>
+              <a:t>44 of 44 injected defects caught</a:t>
             </a:r>
             <a:endParaRPr lang="en-US" sz="1400" dirty="0"/>
           </a:p>
@@ -10535,7 +10535,7 @@
                   <a:schemeClr val="tx1"/>
                 </a:solidFill>
               </a:rPr>
-              <a:t>Budi, Bandung branch: To budi@..., CC branch.bdg@... only. The attachment contains Budi's own policy and NIK and opens only with his date of birth. Surabaya never receives anything about Budi.</a:t>
+              <a:t>Budi W*****, Bandung branch: To customer.0002@gmail.example, CC branch.bdg@nusantaralife.example only. The attachment holds Budi's own policy and masked NIK and opens only with his date of birth. Surabaya never receives anything about Budi.</a:t>
             </a:r>
             <a:endParaRPr lang="en-US" sz="1500" dirty="0"/>
           </a:p>
@@ -11349,7 +11349,7 @@
                 <a:ea typeface="Cambria" pitchFamily="34" charset="-122"/>
                 <a:cs typeface="Cambria" pitchFamily="34" charset="-120"/>
               </a:rPr>
-              <a:t>All 42 deliberately injected defects were caught and none reached a customer</a:t>
+              <a:t>All 44 deliberately injected defects were caught and none reached a customer</a:t>
             </a:r>
             <a:endParaRPr lang="en-US" sz="2400" dirty="0"/>
           </a:p>
@@ -11431,7 +11431,7 @@
                 <a:ea typeface="Cambria" pitchFamily="34" charset="-122"/>
                 <a:cs typeface="Cambria" pitchFamily="34" charset="-120"/>
               </a:rPr>
-              <a:t>42 / 42</a:t>
+              <a:t>44 / 44</a:t>
             </a:r>
             <a:endParaRPr lang="en-US" sz="3600" dirty="0"/>
           </a:p>
@@ -11818,7 +11818,7 @@
                 <a:ea typeface="Cambria" pitchFamily="34" charset="-122"/>
                 <a:cs typeface="Cambria" pitchFamily="34" charset="-120"/>
               </a:rPr>
-              <a:t>An independent re-check of all 411 sent emails shows each branch received only its own customers</a:t>
+              <a:t>An independent re-check of all 409 sent emails shows each branch received only its own customers</a:t>
             </a:r>
             <a:endParaRPr lang="en-US" sz="2400" dirty="0"/>
           </a:p>
@@ -12395,7 +12395,7 @@
                           <a:ea typeface="Calibri" pitchFamily="34" charset="-122"/>
                           <a:cs typeface="Calibri" pitchFamily="34" charset="-120"/>
                         </a:rPr>
-                        <a:t>78</a:t>
+                        <a:t>82</a:t>
                       </a:r>
                       <a:endParaRPr lang="en-US" sz="1400" dirty="0">
                         <a:latin typeface="Calibri" charset="0"/>
@@ -12938,7 +12938,7 @@
                           <a:ea typeface="Calibri" pitchFamily="34" charset="-122"/>
                           <a:cs typeface="Calibri" pitchFamily="34" charset="-120"/>
                         </a:rPr>
-                        <a:t>79</a:t>
+                        <a:t>53</a:t>
                       </a:r>
                       <a:endParaRPr lang="en-US" sz="1400" dirty="0">
                         <a:latin typeface="Calibri" charset="0"/>
@@ -13481,7 +13481,7 @@
                           <a:ea typeface="Calibri" pitchFamily="34" charset="-122"/>
                           <a:cs typeface="Calibri" pitchFamily="34" charset="-120"/>
                         </a:rPr>
-                        <a:t>77</a:t>
+                        <a:t>68</a:t>
                       </a:r>
                       <a:endParaRPr lang="en-US" sz="1400" dirty="0">
                         <a:latin typeface="Calibri" charset="0"/>
@@ -14024,7 +14024,7 @@
                           <a:ea typeface="Calibri" pitchFamily="34" charset="-122"/>
                           <a:cs typeface="Calibri" pitchFamily="34" charset="-120"/>
                         </a:rPr>
-                        <a:t>64</a:t>
+                        <a:t>65</a:t>
                       </a:r>
                       <a:endParaRPr lang="en-US" sz="1400" dirty="0">
                         <a:latin typeface="Calibri" charset="0"/>
@@ -14567,7 +14567,7 @@
                           <a:ea typeface="Calibri" pitchFamily="34" charset="-122"/>
                           <a:cs typeface="Calibri" pitchFamily="34" charset="-120"/>
                         </a:rPr>
-                        <a:t>50</a:t>
+                        <a:t>67</a:t>
                       </a:r>
                       <a:endParaRPr lang="en-US" sz="1400" dirty="0">
                         <a:latin typeface="Calibri" charset="0"/>
@@ -15110,7 +15110,7 @@
                           <a:ea typeface="Calibri" pitchFamily="34" charset="-122"/>
                           <a:cs typeface="Calibri" pitchFamily="34" charset="-120"/>
                         </a:rPr>
-                        <a:t>63</a:t>
+                        <a:t>74</a:t>
                       </a:r>
                       <a:endParaRPr lang="en-US" sz="1400" dirty="0">
                         <a:latin typeface="Calibri" charset="0"/>
@@ -15256,7 +15256,7 @@
                   <a:schemeClr val="accent2"/>
                 </a:solidFill>
               </a:rPr>
-              <a:t>411 / 411  </a:t>
+              <a:t>409 / 409  </a:t>
             </a:r>
             <a:pPr indent="0" marL="0">
               <a:buNone/>
@@ -15327,7 +15327,7 @@
                   <a:schemeClr val="accent2"/>
                 </a:solidFill>
               </a:rPr>
-              <a:t>411 / 411  </a:t>
+              <a:t>409 / 409  </a:t>
             </a:r>
             <a:pPr indent="0" marL="0">
               <a:buNone/>
@@ -15398,7 +15398,7 @@
                   <a:schemeClr val="accent2"/>
                 </a:solidFill>
               </a:rPr>
-              <a:t>411 / 411  </a:t>
+              <a:t>409 / 409  </a:t>
             </a:r>
             <a:pPr indent="0" marL="0">
               <a:buNone/>
@@ -15469,7 +15469,7 @@
                   <a:schemeClr val="accent2"/>
                 </a:solidFill>
               </a:rPr>
-              <a:t>411 / 411  </a:t>
+              <a:t>409 / 409  </a:t>
             </a:r>
             <a:pPr indent="0" marL="0">
               <a:buNone/>

</xml_diff>